<commit_message>
Add pptx generator scripts and refresh documentation decks
Regenerate the edge function, ai-image, and product-variant decks and
check in the Python scripts used to build them so the decks can be
reproduced/updated going forward.

Co-Authored-By: Claude Sonnet 5 <noreply@anthropic.com>
</commit_message>
<xml_diff>
--- a/docs/EDS-EdgeFunction-Guide.pptx
+++ b/docs/EDS-EdgeFunction-Guide.pptx
@@ -5,19 +5,20 @@
     <p:sldMasterId id="2147483648" r:id="rId1"/>
   </p:sldMasterIdLst>
   <p:sldIdLst>
-    <p:sldId id="256" r:id="rId7"/>
-    <p:sldId id="257" r:id="rId8"/>
-    <p:sldId id="258" r:id="rId9"/>
-    <p:sldId id="259" r:id="rId10"/>
-    <p:sldId id="260" r:id="rId11"/>
-    <p:sldId id="261" r:id="rId12"/>
-    <p:sldId id="262" r:id="rId13"/>
-    <p:sldId id="263" r:id="rId14"/>
-    <p:sldId id="264" r:id="rId15"/>
-    <p:sldId id="265" r:id="rId16"/>
-    <p:sldId id="266" r:id="rId17"/>
+    <p:sldId id="256" r:id="rId2"/>
+    <p:sldId id="257" r:id="rId3"/>
+    <p:sldId id="258" r:id="rId4"/>
+    <p:sldId id="259" r:id="rId5"/>
+    <p:sldId id="260" r:id="rId6"/>
+    <p:sldId id="261" r:id="rId7"/>
+    <p:sldId id="262" r:id="rId8"/>
+    <p:sldId id="263" r:id="rId9"/>
+    <p:sldId id="264" r:id="rId10"/>
+    <p:sldId id="265" r:id="rId11"/>
+    <p:sldId id="267" r:id="rId12"/>
+    <p:sldId id="266" r:id="rId13"/>
   </p:sldIdLst>
-  <p:sldSz cx="12188952" cy="6858000" type="screen4x3"/>
+  <p:sldSz cx="12188825" cy="6858000"/>
   <p:notesSz cx="6858000" cy="9144000"/>
   <p:defaultTextStyle>
     <a:defPPr>
@@ -114,7 +115,60 @@
       </a:defRPr>
     </a:lvl9pPr>
   </p:defaultTextStyle>
+  <p:extLst>
+    <p:ext uri="{EFAFB233-063F-42B5-8137-9DF3F51BA10A}">
+      <p15:sldGuideLst xmlns:p15="http://schemas.microsoft.com/office/powerpoint/2012/main">
+        <p15:guide id="1" orient="horz" pos="2160">
+          <p15:clr>
+            <a:srgbClr val="A4A3A4"/>
+          </p15:clr>
+        </p15:guide>
+        <p15:guide id="2" pos="2880">
+          <p15:clr>
+            <a:srgbClr val="A4A3A4"/>
+          </p15:clr>
+        </p15:guide>
+      </p15:sldGuideLst>
+    </p:ext>
+  </p:extLst>
 </p:presentation>
+</file>
+
+<file path=ppt/revisionInfo.xml><?xml version="1.0" encoding="utf-8"?>
+<p1510:revInfo xmlns:a="http://schemas.openxmlformats.org/drawingml/2006/main" xmlns:r="http://schemas.openxmlformats.org/officeDocument/2006/relationships" xmlns:p1510="http://schemas.microsoft.com/office/powerpoint/2015/10/main">
+  <p1510:revLst>
+    <p1510:client id="{BAE9ACD5-5E9C-354E-8293-0BF86287B3D4}" v="1" dt="2026-08-20T06:57:19.892"/>
+  </p1510:revLst>
+</p1510:revInfo>
+</file>
+
+<file path=ppt/changesInfos/changesInfo1.xml><?xml version="1.0" encoding="utf-8"?>
+<pc:chgInfo xmlns:a="http://schemas.openxmlformats.org/drawingml/2006/main" xmlns:r="http://schemas.openxmlformats.org/officeDocument/2006/relationships" xmlns:ac="http://schemas.microsoft.com/office/drawing/2013/main/command" xmlns:pc="http://schemas.microsoft.com/office/powerpoint/2013/main/command">
+  <pc:docChgLst>
+    <pc:chgData name="Franck Sevin" userId="82d950c0-7bb5-4310-a4fc-a877d4bbe588" providerId="ADAL" clId="{EB9E244D-3F8B-59DF-801C-03BB392BC6F1}"/>
+    <pc:docChg chg="addSld modSld">
+      <pc:chgData name="Franck Sevin" userId="82d950c0-7bb5-4310-a4fc-a877d4bbe588" providerId="ADAL" clId="{EB9E244D-3F8B-59DF-801C-03BB392BC6F1}" dt="2026-08-20T07:27:59.999" v="13" actId="14100"/>
+      <pc:docMkLst>
+        <pc:docMk/>
+      </pc:docMkLst>
+      <pc:sldChg chg="addSp modSp new mod">
+        <pc:chgData name="Franck Sevin" userId="82d950c0-7bb5-4310-a4fc-a877d4bbe588" providerId="ADAL" clId="{EB9E244D-3F8B-59DF-801C-03BB392BC6F1}" dt="2026-08-20T07:27:59.999" v="13" actId="14100"/>
+        <pc:sldMkLst>
+          <pc:docMk/>
+          <pc:sldMk cId="3425204263" sldId="267"/>
+        </pc:sldMkLst>
+        <pc:picChg chg="add mod">
+          <ac:chgData name="Franck Sevin" userId="82d950c0-7bb5-4310-a4fc-a877d4bbe588" providerId="ADAL" clId="{EB9E244D-3F8B-59DF-801C-03BB392BC6F1}" dt="2026-08-20T07:27:59.999" v="13" actId="14100"/>
+          <ac:picMkLst>
+            <pc:docMk/>
+            <pc:sldMk cId="3425204263" sldId="267"/>
+            <ac:picMk id="2" creationId="{E36FA3BE-29D3-AC8A-6B6B-D326B3743C46}"/>
+          </ac:picMkLst>
+        </pc:picChg>
+      </pc:sldChg>
+    </pc:docChg>
+  </pc:docChgLst>
+</pc:chgInfo>
 </file>
 
 <file path=ppt/slideLayouts/slideLayout1.xml><?xml version="1.0" encoding="utf-8"?>
@@ -155,10 +209,9 @@
           <a:lstStyle/>
           <a:p>
             <a:r>
-              <a:rPr lang="en-US" smtClean="0"/>
+              <a:rPr lang="en-US"/>
               <a:t>Click to edit Master title style</a:t>
             </a:r>
-            <a:endParaRPr lang="en-US"/>
           </a:p>
         </p:txBody>
       </p:sp>
@@ -274,10 +327,9 @@
           </a:lstStyle>
           <a:p>
             <a:r>
-              <a:rPr lang="en-US" smtClean="0"/>
+              <a:rPr lang="en-US"/>
               <a:t>Click to edit Master subtitle style</a:t>
             </a:r>
-            <a:endParaRPr lang="en-US"/>
           </a:p>
         </p:txBody>
       </p:sp>
@@ -298,7 +350,7 @@
           <a:p>
             <a:fld id="{5BCAD085-E8A6-8845-BD4E-CB4CCA059FC4}" type="datetimeFigureOut">
               <a:rPr lang="en-US" smtClean="0"/>
-              <a:t>1/27/13</a:t>
+              <a:t>8/20/26</a:t>
             </a:fld>
             <a:endParaRPr lang="en-US"/>
           </a:p>
@@ -392,10 +444,9 @@
           <a:lstStyle/>
           <a:p>
             <a:r>
-              <a:rPr lang="en-US" smtClean="0"/>
+              <a:rPr lang="en-US"/>
               <a:t>Click to edit Master title style</a:t>
             </a:r>
-            <a:endParaRPr lang="en-US"/>
           </a:p>
         </p:txBody>
       </p:sp>
@@ -416,38 +467,37 @@
           <a:p>
             <a:pPr lvl="0"/>
             <a:r>
-              <a:rPr lang="en-US" smtClean="0"/>
+              <a:rPr lang="en-US"/>
               <a:t>Click to edit Master text styles</a:t>
             </a:r>
           </a:p>
           <a:p>
             <a:pPr lvl="1"/>
             <a:r>
-              <a:rPr lang="en-US" smtClean="0"/>
+              <a:rPr lang="en-US"/>
               <a:t>Second level</a:t>
             </a:r>
           </a:p>
           <a:p>
             <a:pPr lvl="2"/>
             <a:r>
-              <a:rPr lang="en-US" smtClean="0"/>
+              <a:rPr lang="en-US"/>
               <a:t>Third level</a:t>
             </a:r>
           </a:p>
           <a:p>
             <a:pPr lvl="3"/>
             <a:r>
-              <a:rPr lang="en-US" smtClean="0"/>
+              <a:rPr lang="en-US"/>
               <a:t>Fourth level</a:t>
             </a:r>
           </a:p>
           <a:p>
             <a:pPr lvl="4"/>
             <a:r>
-              <a:rPr lang="en-US" smtClean="0"/>
+              <a:rPr lang="en-US"/>
               <a:t>Fifth level</a:t>
             </a:r>
-            <a:endParaRPr lang="en-US"/>
           </a:p>
         </p:txBody>
       </p:sp>
@@ -468,7 +518,7 @@
           <a:p>
             <a:fld id="{5BCAD085-E8A6-8845-BD4E-CB4CCA059FC4}" type="datetimeFigureOut">
               <a:rPr lang="en-US" smtClean="0"/>
-              <a:t>1/27/13</a:t>
+              <a:t>8/20/26</a:t>
             </a:fld>
             <a:endParaRPr lang="en-US"/>
           </a:p>
@@ -567,10 +617,9 @@
           <a:lstStyle/>
           <a:p>
             <a:r>
-              <a:rPr lang="en-US" smtClean="0"/>
+              <a:rPr lang="en-US"/>
               <a:t>Click to edit Master title style</a:t>
             </a:r>
-            <a:endParaRPr lang="en-US"/>
           </a:p>
         </p:txBody>
       </p:sp>
@@ -596,38 +645,37 @@
           <a:p>
             <a:pPr lvl="0"/>
             <a:r>
-              <a:rPr lang="en-US" smtClean="0"/>
+              <a:rPr lang="en-US"/>
               <a:t>Click to edit Master text styles</a:t>
             </a:r>
           </a:p>
           <a:p>
             <a:pPr lvl="1"/>
             <a:r>
-              <a:rPr lang="en-US" smtClean="0"/>
+              <a:rPr lang="en-US"/>
               <a:t>Second level</a:t>
             </a:r>
           </a:p>
           <a:p>
             <a:pPr lvl="2"/>
             <a:r>
-              <a:rPr lang="en-US" smtClean="0"/>
+              <a:rPr lang="en-US"/>
               <a:t>Third level</a:t>
             </a:r>
           </a:p>
           <a:p>
             <a:pPr lvl="3"/>
             <a:r>
-              <a:rPr lang="en-US" smtClean="0"/>
+              <a:rPr lang="en-US"/>
               <a:t>Fourth level</a:t>
             </a:r>
           </a:p>
           <a:p>
             <a:pPr lvl="4"/>
             <a:r>
-              <a:rPr lang="en-US" smtClean="0"/>
+              <a:rPr lang="en-US"/>
               <a:t>Fifth level</a:t>
             </a:r>
-            <a:endParaRPr lang="en-US"/>
           </a:p>
         </p:txBody>
       </p:sp>
@@ -648,7 +696,7 @@
           <a:p>
             <a:fld id="{5BCAD085-E8A6-8845-BD4E-CB4CCA059FC4}" type="datetimeFigureOut">
               <a:rPr lang="en-US" smtClean="0"/>
-              <a:t>1/27/13</a:t>
+              <a:t>8/20/26</a:t>
             </a:fld>
             <a:endParaRPr lang="en-US"/>
           </a:p>
@@ -742,10 +790,9 @@
           <a:lstStyle/>
           <a:p>
             <a:r>
-              <a:rPr lang="en-US" smtClean="0"/>
+              <a:rPr lang="en-US"/>
               <a:t>Click to edit Master title style</a:t>
             </a:r>
-            <a:endParaRPr lang="en-US"/>
           </a:p>
         </p:txBody>
       </p:sp>
@@ -766,38 +813,37 @@
           <a:p>
             <a:pPr lvl="0"/>
             <a:r>
-              <a:rPr lang="en-US" smtClean="0"/>
+              <a:rPr lang="en-US"/>
               <a:t>Click to edit Master text styles</a:t>
             </a:r>
           </a:p>
           <a:p>
             <a:pPr lvl="1"/>
             <a:r>
-              <a:rPr lang="en-US" smtClean="0"/>
+              <a:rPr lang="en-US"/>
               <a:t>Second level</a:t>
             </a:r>
           </a:p>
           <a:p>
             <a:pPr lvl="2"/>
             <a:r>
-              <a:rPr lang="en-US" smtClean="0"/>
+              <a:rPr lang="en-US"/>
               <a:t>Third level</a:t>
             </a:r>
           </a:p>
           <a:p>
             <a:pPr lvl="3"/>
             <a:r>
-              <a:rPr lang="en-US" smtClean="0"/>
+              <a:rPr lang="en-US"/>
               <a:t>Fourth level</a:t>
             </a:r>
           </a:p>
           <a:p>
             <a:pPr lvl="4"/>
             <a:r>
-              <a:rPr lang="en-US" smtClean="0"/>
+              <a:rPr lang="en-US"/>
               <a:t>Fifth level</a:t>
             </a:r>
-            <a:endParaRPr lang="en-US"/>
           </a:p>
         </p:txBody>
       </p:sp>
@@ -818,7 +864,7 @@
           <a:p>
             <a:fld id="{5BCAD085-E8A6-8845-BD4E-CB4CCA059FC4}" type="datetimeFigureOut">
               <a:rPr lang="en-US" smtClean="0"/>
-              <a:t>1/27/13</a:t>
+              <a:t>8/20/26</a:t>
             </a:fld>
             <a:endParaRPr lang="en-US"/>
           </a:p>
@@ -921,10 +967,9 @@
           </a:lstStyle>
           <a:p>
             <a:r>
-              <a:rPr lang="en-US" smtClean="0"/>
+              <a:rPr lang="en-US"/>
               <a:t>Click to edit Master title style</a:t>
             </a:r>
-            <a:endParaRPr lang="en-US"/>
           </a:p>
         </p:txBody>
       </p:sp>
@@ -1041,7 +1086,7 @@
           <a:p>
             <a:pPr lvl="0"/>
             <a:r>
-              <a:rPr lang="en-US" smtClean="0"/>
+              <a:rPr lang="en-US"/>
               <a:t>Click to edit Master text styles</a:t>
             </a:r>
           </a:p>
@@ -1064,7 +1109,7 @@
           <a:p>
             <a:fld id="{5BCAD085-E8A6-8845-BD4E-CB4CCA059FC4}" type="datetimeFigureOut">
               <a:rPr lang="en-US" smtClean="0"/>
-              <a:t>1/27/13</a:t>
+              <a:t>8/20/26</a:t>
             </a:fld>
             <a:endParaRPr lang="en-US"/>
           </a:p>
@@ -1158,10 +1203,9 @@
           <a:lstStyle/>
           <a:p>
             <a:r>
-              <a:rPr lang="en-US" smtClean="0"/>
+              <a:rPr lang="en-US"/>
               <a:t>Click to edit Master title style</a:t>
             </a:r>
-            <a:endParaRPr lang="en-US"/>
           </a:p>
         </p:txBody>
       </p:sp>
@@ -1215,38 +1259,37 @@
           <a:p>
             <a:pPr lvl="0"/>
             <a:r>
-              <a:rPr lang="en-US" smtClean="0"/>
+              <a:rPr lang="en-US"/>
               <a:t>Click to edit Master text styles</a:t>
             </a:r>
           </a:p>
           <a:p>
             <a:pPr lvl="1"/>
             <a:r>
-              <a:rPr lang="en-US" smtClean="0"/>
+              <a:rPr lang="en-US"/>
               <a:t>Second level</a:t>
             </a:r>
           </a:p>
           <a:p>
             <a:pPr lvl="2"/>
             <a:r>
-              <a:rPr lang="en-US" smtClean="0"/>
+              <a:rPr lang="en-US"/>
               <a:t>Third level</a:t>
             </a:r>
           </a:p>
           <a:p>
             <a:pPr lvl="3"/>
             <a:r>
-              <a:rPr lang="en-US" smtClean="0"/>
+              <a:rPr lang="en-US"/>
               <a:t>Fourth level</a:t>
             </a:r>
           </a:p>
           <a:p>
             <a:pPr lvl="4"/>
             <a:r>
-              <a:rPr lang="en-US" smtClean="0"/>
+              <a:rPr lang="en-US"/>
               <a:t>Fifth level</a:t>
             </a:r>
-            <a:endParaRPr lang="en-US"/>
           </a:p>
         </p:txBody>
       </p:sp>
@@ -1300,38 +1343,37 @@
           <a:p>
             <a:pPr lvl="0"/>
             <a:r>
-              <a:rPr lang="en-US" smtClean="0"/>
+              <a:rPr lang="en-US"/>
               <a:t>Click to edit Master text styles</a:t>
             </a:r>
           </a:p>
           <a:p>
             <a:pPr lvl="1"/>
             <a:r>
-              <a:rPr lang="en-US" smtClean="0"/>
+              <a:rPr lang="en-US"/>
               <a:t>Second level</a:t>
             </a:r>
           </a:p>
           <a:p>
             <a:pPr lvl="2"/>
             <a:r>
-              <a:rPr lang="en-US" smtClean="0"/>
+              <a:rPr lang="en-US"/>
               <a:t>Third level</a:t>
             </a:r>
           </a:p>
           <a:p>
             <a:pPr lvl="3"/>
             <a:r>
-              <a:rPr lang="en-US" smtClean="0"/>
+              <a:rPr lang="en-US"/>
               <a:t>Fourth level</a:t>
             </a:r>
           </a:p>
           <a:p>
             <a:pPr lvl="4"/>
             <a:r>
-              <a:rPr lang="en-US" smtClean="0"/>
+              <a:rPr lang="en-US"/>
               <a:t>Fifth level</a:t>
             </a:r>
-            <a:endParaRPr lang="en-US"/>
           </a:p>
         </p:txBody>
       </p:sp>
@@ -1352,7 +1394,7 @@
           <a:p>
             <a:fld id="{5BCAD085-E8A6-8845-BD4E-CB4CCA059FC4}" type="datetimeFigureOut">
               <a:rPr lang="en-US" smtClean="0"/>
-              <a:t>1/27/13</a:t>
+              <a:t>8/20/26</a:t>
             </a:fld>
             <a:endParaRPr lang="en-US"/>
           </a:p>
@@ -1450,10 +1492,9 @@
           </a:lstStyle>
           <a:p>
             <a:r>
-              <a:rPr lang="en-US" smtClean="0"/>
+              <a:rPr lang="en-US"/>
               <a:t>Click to edit Master title style</a:t>
             </a:r>
-            <a:endParaRPr lang="en-US"/>
           </a:p>
         </p:txBody>
       </p:sp>
@@ -1516,7 +1557,7 @@
           <a:p>
             <a:pPr lvl="0"/>
             <a:r>
-              <a:rPr lang="en-US" smtClean="0"/>
+              <a:rPr lang="en-US"/>
               <a:t>Click to edit Master text styles</a:t>
             </a:r>
           </a:p>
@@ -1572,38 +1613,37 @@
           <a:p>
             <a:pPr lvl="0"/>
             <a:r>
-              <a:rPr lang="en-US" smtClean="0"/>
+              <a:rPr lang="en-US"/>
               <a:t>Click to edit Master text styles</a:t>
             </a:r>
           </a:p>
           <a:p>
             <a:pPr lvl="1"/>
             <a:r>
-              <a:rPr lang="en-US" smtClean="0"/>
+              <a:rPr lang="en-US"/>
               <a:t>Second level</a:t>
             </a:r>
           </a:p>
           <a:p>
             <a:pPr lvl="2"/>
             <a:r>
-              <a:rPr lang="en-US" smtClean="0"/>
+              <a:rPr lang="en-US"/>
               <a:t>Third level</a:t>
             </a:r>
           </a:p>
           <a:p>
             <a:pPr lvl="3"/>
             <a:r>
-              <a:rPr lang="en-US" smtClean="0"/>
+              <a:rPr lang="en-US"/>
               <a:t>Fourth level</a:t>
             </a:r>
           </a:p>
           <a:p>
             <a:pPr lvl="4"/>
             <a:r>
-              <a:rPr lang="en-US" smtClean="0"/>
+              <a:rPr lang="en-US"/>
               <a:t>Fifth level</a:t>
             </a:r>
-            <a:endParaRPr lang="en-US"/>
           </a:p>
         </p:txBody>
       </p:sp>
@@ -1666,7 +1706,7 @@
           <a:p>
             <a:pPr lvl="0"/>
             <a:r>
-              <a:rPr lang="en-US" smtClean="0"/>
+              <a:rPr lang="en-US"/>
               <a:t>Click to edit Master text styles</a:t>
             </a:r>
           </a:p>
@@ -1722,38 +1762,37 @@
           <a:p>
             <a:pPr lvl="0"/>
             <a:r>
-              <a:rPr lang="en-US" smtClean="0"/>
+              <a:rPr lang="en-US"/>
               <a:t>Click to edit Master text styles</a:t>
             </a:r>
           </a:p>
           <a:p>
             <a:pPr lvl="1"/>
             <a:r>
-              <a:rPr lang="en-US" smtClean="0"/>
+              <a:rPr lang="en-US"/>
               <a:t>Second level</a:t>
             </a:r>
           </a:p>
           <a:p>
             <a:pPr lvl="2"/>
             <a:r>
-              <a:rPr lang="en-US" smtClean="0"/>
+              <a:rPr lang="en-US"/>
               <a:t>Third level</a:t>
             </a:r>
           </a:p>
           <a:p>
             <a:pPr lvl="3"/>
             <a:r>
-              <a:rPr lang="en-US" smtClean="0"/>
+              <a:rPr lang="en-US"/>
               <a:t>Fourth level</a:t>
             </a:r>
           </a:p>
           <a:p>
             <a:pPr lvl="4"/>
             <a:r>
-              <a:rPr lang="en-US" smtClean="0"/>
+              <a:rPr lang="en-US"/>
               <a:t>Fifth level</a:t>
             </a:r>
-            <a:endParaRPr lang="en-US"/>
           </a:p>
         </p:txBody>
       </p:sp>
@@ -1774,7 +1813,7 @@
           <a:p>
             <a:fld id="{5BCAD085-E8A6-8845-BD4E-CB4CCA059FC4}" type="datetimeFigureOut">
               <a:rPr lang="en-US" smtClean="0"/>
-              <a:t>1/27/13</a:t>
+              <a:t>8/20/26</a:t>
             </a:fld>
             <a:endParaRPr lang="en-US"/>
           </a:p>
@@ -1868,10 +1907,9 @@
           <a:lstStyle/>
           <a:p>
             <a:r>
-              <a:rPr lang="en-US" smtClean="0"/>
+              <a:rPr lang="en-US"/>
               <a:t>Click to edit Master title style</a:t>
             </a:r>
-            <a:endParaRPr lang="en-US"/>
           </a:p>
         </p:txBody>
       </p:sp>
@@ -1892,7 +1930,7 @@
           <a:p>
             <a:fld id="{5BCAD085-E8A6-8845-BD4E-CB4CCA059FC4}" type="datetimeFigureOut">
               <a:rPr lang="en-US" smtClean="0"/>
-              <a:t>1/27/13</a:t>
+              <a:t>8/20/26</a:t>
             </a:fld>
             <a:endParaRPr lang="en-US"/>
           </a:p>
@@ -1987,7 +2025,7 @@
           <a:p>
             <a:fld id="{5BCAD085-E8A6-8845-BD4E-CB4CCA059FC4}" type="datetimeFigureOut">
               <a:rPr lang="en-US" smtClean="0"/>
-              <a:t>1/27/13</a:t>
+              <a:t>8/20/26</a:t>
             </a:fld>
             <a:endParaRPr lang="en-US"/>
           </a:p>
@@ -2090,10 +2128,9 @@
           </a:lstStyle>
           <a:p>
             <a:r>
-              <a:rPr lang="en-US" smtClean="0"/>
+              <a:rPr lang="en-US"/>
               <a:t>Click to edit Master title style</a:t>
             </a:r>
-            <a:endParaRPr lang="en-US"/>
           </a:p>
         </p:txBody>
       </p:sp>
@@ -2147,38 +2184,37 @@
           <a:p>
             <a:pPr lvl="0"/>
             <a:r>
-              <a:rPr lang="en-US" smtClean="0"/>
+              <a:rPr lang="en-US"/>
               <a:t>Click to edit Master text styles</a:t>
             </a:r>
           </a:p>
           <a:p>
             <a:pPr lvl="1"/>
             <a:r>
-              <a:rPr lang="en-US" smtClean="0"/>
+              <a:rPr lang="en-US"/>
               <a:t>Second level</a:t>
             </a:r>
           </a:p>
           <a:p>
             <a:pPr lvl="2"/>
             <a:r>
-              <a:rPr lang="en-US" smtClean="0"/>
+              <a:rPr lang="en-US"/>
               <a:t>Third level</a:t>
             </a:r>
           </a:p>
           <a:p>
             <a:pPr lvl="3"/>
             <a:r>
-              <a:rPr lang="en-US" smtClean="0"/>
+              <a:rPr lang="en-US"/>
               <a:t>Fourth level</a:t>
             </a:r>
           </a:p>
           <a:p>
             <a:pPr lvl="4"/>
             <a:r>
-              <a:rPr lang="en-US" smtClean="0"/>
+              <a:rPr lang="en-US"/>
               <a:t>Fifth level</a:t>
             </a:r>
-            <a:endParaRPr lang="en-US"/>
           </a:p>
         </p:txBody>
       </p:sp>
@@ -2241,7 +2277,7 @@
           <a:p>
             <a:pPr lvl="0"/>
             <a:r>
-              <a:rPr lang="en-US" smtClean="0"/>
+              <a:rPr lang="en-US"/>
               <a:t>Click to edit Master text styles</a:t>
             </a:r>
           </a:p>
@@ -2264,7 +2300,7 @@
           <a:p>
             <a:fld id="{5BCAD085-E8A6-8845-BD4E-CB4CCA059FC4}" type="datetimeFigureOut">
               <a:rPr lang="en-US" smtClean="0"/>
-              <a:t>1/27/13</a:t>
+              <a:t>8/20/26</a:t>
             </a:fld>
             <a:endParaRPr lang="en-US"/>
           </a:p>
@@ -2367,10 +2403,9 @@
           </a:lstStyle>
           <a:p>
             <a:r>
-              <a:rPr lang="en-US" smtClean="0"/>
+              <a:rPr lang="en-US"/>
               <a:t>Click to edit Master title style</a:t>
             </a:r>
-            <a:endParaRPr lang="en-US"/>
           </a:p>
         </p:txBody>
       </p:sp>
@@ -2494,7 +2529,7 @@
           <a:p>
             <a:pPr lvl="0"/>
             <a:r>
-              <a:rPr lang="en-US" smtClean="0"/>
+              <a:rPr lang="en-US"/>
               <a:t>Click to edit Master text styles</a:t>
             </a:r>
           </a:p>
@@ -2517,7 +2552,7 @@
           <a:p>
             <a:fld id="{5BCAD085-E8A6-8845-BD4E-CB4CCA059FC4}" type="datetimeFigureOut">
               <a:rPr lang="en-US" smtClean="0"/>
-              <a:t>1/27/13</a:t>
+              <a:t>8/20/26</a:t>
             </a:fld>
             <a:endParaRPr lang="en-US"/>
           </a:p>
@@ -2626,10 +2661,9 @@
           <a:lstStyle/>
           <a:p>
             <a:r>
-              <a:rPr lang="en-US" smtClean="0"/>
+              <a:rPr lang="en-US"/>
               <a:t>Click to edit Master title style</a:t>
             </a:r>
-            <a:endParaRPr lang="en-US"/>
           </a:p>
         </p:txBody>
       </p:sp>
@@ -2660,38 +2694,37 @@
           <a:p>
             <a:pPr lvl="0"/>
             <a:r>
-              <a:rPr lang="en-US" smtClean="0"/>
+              <a:rPr lang="en-US"/>
               <a:t>Click to edit Master text styles</a:t>
             </a:r>
           </a:p>
           <a:p>
             <a:pPr lvl="1"/>
             <a:r>
-              <a:rPr lang="en-US" smtClean="0"/>
+              <a:rPr lang="en-US"/>
               <a:t>Second level</a:t>
             </a:r>
           </a:p>
           <a:p>
             <a:pPr lvl="2"/>
             <a:r>
-              <a:rPr lang="en-US" smtClean="0"/>
+              <a:rPr lang="en-US"/>
               <a:t>Third level</a:t>
             </a:r>
           </a:p>
           <a:p>
             <a:pPr lvl="3"/>
             <a:r>
-              <a:rPr lang="en-US" smtClean="0"/>
+              <a:rPr lang="en-US"/>
               <a:t>Fourth level</a:t>
             </a:r>
           </a:p>
           <a:p>
             <a:pPr lvl="4"/>
             <a:r>
-              <a:rPr lang="en-US" smtClean="0"/>
+              <a:rPr lang="en-US"/>
               <a:t>Fifth level</a:t>
             </a:r>
-            <a:endParaRPr lang="en-US"/>
           </a:p>
         </p:txBody>
       </p:sp>
@@ -2730,7 +2763,7 @@
           <a:p>
             <a:fld id="{5BCAD085-E8A6-8845-BD4E-CB4CCA059FC4}" type="datetimeFigureOut">
               <a:rPr lang="en-US" smtClean="0"/>
-              <a:t>1/27/13</a:t>
+              <a:t>8/20/26</a:t>
             </a:fld>
             <a:endParaRPr lang="en-US"/>
           </a:p>
@@ -3089,7 +3122,7 @@
 </file>
 
 <file path=ppt/slides/slide1.xml><?xml version="1.0" encoding="utf-8"?>
-<p:sld xmlns:a="http://schemas.openxmlformats.org/drawingml/2006/main" xmlns:p="http://schemas.openxmlformats.org/presentationml/2006/main" xmlns:r="http://schemas.openxmlformats.org/officeDocument/2006/relationships">
+<p:sld xmlns:a="http://schemas.openxmlformats.org/drawingml/2006/main" xmlns:r="http://schemas.openxmlformats.org/officeDocument/2006/relationships" xmlns:p="http://schemas.openxmlformats.org/presentationml/2006/main">
   <p:cSld>
     <p:spTree>
       <p:nvGrpSpPr>
@@ -3097,7 +3130,14 @@
         <p:cNvGrpSpPr/>
         <p:nvPr/>
       </p:nvGrpSpPr>
-      <p:grpSpPr/>
+      <p:grpSpPr>
+        <a:xfrm>
+          <a:off x="0" y="0"/>
+          <a:ext cx="0" cy="0"/>
+          <a:chOff x="0" y="0"/>
+          <a:chExt cx="0" cy="0"/>
+        </a:xfrm>
+      </p:grpSpPr>
       <p:sp>
         <p:nvSpPr>
           <p:cNvPr id="2" name="Rectangle 1"/>
@@ -3138,6 +3178,7 @@
           <a:lstStyle/>
           <a:p>
             <a:pPr algn="ctr"/>
+            <a:endParaRPr/>
           </a:p>
         </p:txBody>
       </p:sp>
@@ -3286,7 +3327,7 @@
 </file>
 
 <file path=ppt/slides/slide10.xml><?xml version="1.0" encoding="utf-8"?>
-<p:sld xmlns:a="http://schemas.openxmlformats.org/drawingml/2006/main" xmlns:p="http://schemas.openxmlformats.org/presentationml/2006/main" xmlns:r="http://schemas.openxmlformats.org/officeDocument/2006/relationships">
+<p:sld xmlns:a="http://schemas.openxmlformats.org/drawingml/2006/main" xmlns:r="http://schemas.openxmlformats.org/officeDocument/2006/relationships" xmlns:p="http://schemas.openxmlformats.org/presentationml/2006/main">
   <p:cSld>
     <p:spTree>
       <p:nvGrpSpPr>
@@ -3294,7 +3335,14 @@
         <p:cNvGrpSpPr/>
         <p:nvPr/>
       </p:nvGrpSpPr>
-      <p:grpSpPr/>
+      <p:grpSpPr>
+        <a:xfrm>
+          <a:off x="0" y="0"/>
+          <a:ext cx="0" cy="0"/>
+          <a:chOff x="0" y="0"/>
+          <a:chExt cx="0" cy="0"/>
+        </a:xfrm>
+      </p:grpSpPr>
       <p:sp>
         <p:nvSpPr>
           <p:cNvPr id="2" name="Rectangle 1"/>
@@ -3335,6 +3383,7 @@
           <a:lstStyle/>
           <a:p>
             <a:pPr algn="ctr"/>
+            <a:endParaRPr/>
           </a:p>
         </p:txBody>
       </p:sp>
@@ -3378,6 +3427,7 @@
           <a:lstStyle/>
           <a:p>
             <a:pPr algn="ctr"/>
+            <a:endParaRPr/>
           </a:p>
         </p:txBody>
       </p:sp>
@@ -3455,6 +3505,7 @@
           <a:lstStyle/>
           <a:p>
             <a:pPr algn="ctr"/>
+            <a:endParaRPr/>
           </a:p>
         </p:txBody>
       </p:sp>
@@ -3498,6 +3549,7 @@
           <a:lstStyle/>
           <a:p>
             <a:pPr algn="ctr"/>
+            <a:endParaRPr/>
           </a:p>
         </p:txBody>
       </p:sp>
@@ -3575,6 +3627,7 @@
           <a:lstStyle/>
           <a:p>
             <a:pPr algn="ctr"/>
+            <a:endParaRPr/>
           </a:p>
         </p:txBody>
       </p:sp>
@@ -3652,6 +3705,7 @@
           <a:lstStyle/>
           <a:p>
             <a:pPr algn="ctr"/>
+            <a:endParaRPr/>
           </a:p>
         </p:txBody>
       </p:sp>
@@ -3729,6 +3783,7 @@
           <a:lstStyle/>
           <a:p>
             <a:pPr algn="ctr"/>
+            <a:endParaRPr/>
           </a:p>
         </p:txBody>
       </p:sp>
@@ -3806,6 +3861,7 @@
           <a:lstStyle/>
           <a:p>
             <a:pPr algn="ctr"/>
+            <a:endParaRPr/>
           </a:p>
         </p:txBody>
       </p:sp>
@@ -3884,6 +3940,7 @@
           <a:lstStyle/>
           <a:p>
             <a:pPr algn="ctr"/>
+            <a:endParaRPr/>
           </a:p>
         </p:txBody>
       </p:sp>
@@ -3962,6 +4019,7 @@
           <a:lstStyle/>
           <a:p>
             <a:pPr algn="ctr"/>
+            <a:endParaRPr/>
           </a:p>
         </p:txBody>
       </p:sp>
@@ -4039,6 +4097,7 @@
           <a:lstStyle/>
           <a:p>
             <a:pPr algn="ctr"/>
+            <a:endParaRPr/>
           </a:p>
         </p:txBody>
       </p:sp>
@@ -4117,6 +4176,7 @@
           <a:lstStyle/>
           <a:p>
             <a:pPr algn="ctr"/>
+            <a:endParaRPr/>
           </a:p>
         </p:txBody>
       </p:sp>
@@ -4195,6 +4255,7 @@
           <a:lstStyle/>
           <a:p>
             <a:pPr algn="ctr"/>
+            <a:endParaRPr/>
           </a:p>
         </p:txBody>
       </p:sp>
@@ -4272,6 +4333,7 @@
           <a:lstStyle/>
           <a:p>
             <a:pPr algn="ctr"/>
+            <a:endParaRPr/>
           </a:p>
         </p:txBody>
       </p:sp>
@@ -4350,6 +4412,7 @@
           <a:lstStyle/>
           <a:p>
             <a:pPr algn="ctr"/>
+            <a:endParaRPr/>
           </a:p>
         </p:txBody>
       </p:sp>
@@ -4428,6 +4491,7 @@
           <a:lstStyle/>
           <a:p>
             <a:pPr algn="ctr"/>
+            <a:endParaRPr/>
           </a:p>
         </p:txBody>
       </p:sp>
@@ -4505,6 +4569,7 @@
           <a:lstStyle/>
           <a:p>
             <a:pPr algn="ctr"/>
+            <a:endParaRPr/>
           </a:p>
         </p:txBody>
       </p:sp>
@@ -4583,6 +4648,7 @@
           <a:lstStyle/>
           <a:p>
             <a:pPr algn="ctr"/>
+            <a:endParaRPr/>
           </a:p>
         </p:txBody>
       </p:sp>
@@ -4661,6 +4727,7 @@
           <a:lstStyle/>
           <a:p>
             <a:pPr algn="ctr"/>
+            <a:endParaRPr/>
           </a:p>
         </p:txBody>
       </p:sp>
@@ -4738,6 +4805,7 @@
           <a:lstStyle/>
           <a:p>
             <a:pPr algn="ctr"/>
+            <a:endParaRPr/>
           </a:p>
         </p:txBody>
       </p:sp>
@@ -4815,6 +4883,7 @@
           <a:lstStyle/>
           <a:p>
             <a:pPr algn="ctr"/>
+            <a:endParaRPr/>
           </a:p>
         </p:txBody>
       </p:sp>
@@ -4893,6 +4962,7 @@
           <a:lstStyle/>
           <a:p>
             <a:pPr algn="ctr"/>
+            <a:endParaRPr/>
           </a:p>
         </p:txBody>
       </p:sp>
@@ -4970,6 +5040,7 @@
           <a:lstStyle/>
           <a:p>
             <a:pPr algn="ctr"/>
+            <a:endParaRPr/>
           </a:p>
         </p:txBody>
       </p:sp>
@@ -5048,6 +5119,7 @@
           <a:lstStyle/>
           <a:p>
             <a:pPr algn="ctr"/>
+            <a:endParaRPr/>
           </a:p>
         </p:txBody>
       </p:sp>
@@ -5163,7 +5235,7 @@
 </file>
 
 <file path=ppt/slides/slide11.xml><?xml version="1.0" encoding="utf-8"?>
-<p:sld xmlns:a="http://schemas.openxmlformats.org/drawingml/2006/main" xmlns:p="http://schemas.openxmlformats.org/presentationml/2006/main" xmlns:r="http://schemas.openxmlformats.org/officeDocument/2006/relationships">
+<p:sld xmlns:a="http://schemas.openxmlformats.org/drawingml/2006/main" xmlns:r="http://schemas.openxmlformats.org/officeDocument/2006/relationships" xmlns:p="http://schemas.openxmlformats.org/presentationml/2006/main">
   <p:cSld>
     <p:spTree>
       <p:nvGrpSpPr>
@@ -5171,7 +5243,74 @@
         <p:cNvGrpSpPr/>
         <p:nvPr/>
       </p:nvGrpSpPr>
-      <p:grpSpPr/>
+      <p:grpSpPr>
+        <a:xfrm>
+          <a:off x="0" y="0"/>
+          <a:ext cx="0" cy="0"/>
+          <a:chOff x="0" y="0"/>
+          <a:chExt cx="0" cy="0"/>
+        </a:xfrm>
+      </p:grpSpPr>
+      <p:pic>
+        <p:nvPicPr>
+          <p:cNvPr id="2" name="Picture 1">
+            <a:extLst>
+              <a:ext uri="{FF2B5EF4-FFF2-40B4-BE49-F238E27FC236}">
+                <a16:creationId xmlns:a16="http://schemas.microsoft.com/office/drawing/2014/main" id="{E36FA3BE-29D3-AC8A-6B6B-D326B3743C46}"/>
+              </a:ext>
+            </a:extLst>
+          </p:cNvPr>
+          <p:cNvPicPr>
+            <a:picLocks noChangeAspect="1"/>
+          </p:cNvPicPr>
+          <p:nvPr/>
+        </p:nvPicPr>
+        <p:blipFill>
+          <a:blip r:embed="rId2"/>
+          <a:stretch>
+            <a:fillRect/>
+          </a:stretch>
+        </p:blipFill>
+        <p:spPr>
+          <a:xfrm>
+            <a:off x="617838" y="660510"/>
+            <a:ext cx="10367319" cy="5831617"/>
+          </a:xfrm>
+          <a:prstGeom prst="rect">
+            <a:avLst/>
+          </a:prstGeom>
+        </p:spPr>
+      </p:pic>
+    </p:spTree>
+    <p:extLst>
+      <p:ext uri="{BB962C8B-B14F-4D97-AF65-F5344CB8AC3E}">
+        <p14:creationId xmlns:p14="http://schemas.microsoft.com/office/powerpoint/2010/main" val="3425204263"/>
+      </p:ext>
+    </p:extLst>
+  </p:cSld>
+  <p:clrMapOvr>
+    <a:masterClrMapping/>
+  </p:clrMapOvr>
+</p:sld>
+</file>
+
+<file path=ppt/slides/slide12.xml><?xml version="1.0" encoding="utf-8"?>
+<p:sld xmlns:a="http://schemas.openxmlformats.org/drawingml/2006/main" xmlns:r="http://schemas.openxmlformats.org/officeDocument/2006/relationships" xmlns:p="http://schemas.openxmlformats.org/presentationml/2006/main">
+  <p:cSld>
+    <p:spTree>
+      <p:nvGrpSpPr>
+        <p:cNvPr id="1" name=""/>
+        <p:cNvGrpSpPr/>
+        <p:nvPr/>
+      </p:nvGrpSpPr>
+      <p:grpSpPr>
+        <a:xfrm>
+          <a:off x="0" y="0"/>
+          <a:ext cx="0" cy="0"/>
+          <a:chOff x="0" y="0"/>
+          <a:chExt cx="0" cy="0"/>
+        </a:xfrm>
+      </p:grpSpPr>
       <p:sp>
         <p:nvSpPr>
           <p:cNvPr id="2" name="Rectangle 1"/>
@@ -5212,6 +5351,7 @@
           <a:lstStyle/>
           <a:p>
             <a:pPr algn="ctr"/>
+            <a:endParaRPr/>
           </a:p>
         </p:txBody>
       </p:sp>
@@ -5258,7 +5398,7 @@
 </file>
 
 <file path=ppt/slides/slide2.xml><?xml version="1.0" encoding="utf-8"?>
-<p:sld xmlns:a="http://schemas.openxmlformats.org/drawingml/2006/main" xmlns:p="http://schemas.openxmlformats.org/presentationml/2006/main" xmlns:r="http://schemas.openxmlformats.org/officeDocument/2006/relationships">
+<p:sld xmlns:a="http://schemas.openxmlformats.org/drawingml/2006/main" xmlns:r="http://schemas.openxmlformats.org/officeDocument/2006/relationships" xmlns:p="http://schemas.openxmlformats.org/presentationml/2006/main">
   <p:cSld>
     <p:spTree>
       <p:nvGrpSpPr>
@@ -5266,7 +5406,14 @@
         <p:cNvGrpSpPr/>
         <p:nvPr/>
       </p:nvGrpSpPr>
-      <p:grpSpPr/>
+      <p:grpSpPr>
+        <a:xfrm>
+          <a:off x="0" y="0"/>
+          <a:ext cx="0" cy="0"/>
+          <a:chOff x="0" y="0"/>
+          <a:chExt cx="0" cy="0"/>
+        </a:xfrm>
+      </p:grpSpPr>
       <p:sp>
         <p:nvSpPr>
           <p:cNvPr id="2" name="Rectangle 1"/>
@@ -5307,6 +5454,7 @@
           <a:lstStyle/>
           <a:p>
             <a:pPr algn="ctr"/>
+            <a:endParaRPr/>
           </a:p>
         </p:txBody>
       </p:sp>
@@ -5350,6 +5498,7 @@
           <a:lstStyle/>
           <a:p>
             <a:pPr algn="ctr"/>
+            <a:endParaRPr/>
           </a:p>
         </p:txBody>
       </p:sp>
@@ -5427,6 +5576,7 @@
           <a:lstStyle/>
           <a:p>
             <a:pPr algn="ctr"/>
+            <a:endParaRPr/>
           </a:p>
         </p:txBody>
       </p:sp>
@@ -5779,7 +5929,7 @@
 </file>
 
 <file path=ppt/slides/slide3.xml><?xml version="1.0" encoding="utf-8"?>
-<p:sld xmlns:a="http://schemas.openxmlformats.org/drawingml/2006/main" xmlns:p="http://schemas.openxmlformats.org/presentationml/2006/main" xmlns:r="http://schemas.openxmlformats.org/officeDocument/2006/relationships">
+<p:sld xmlns:a="http://schemas.openxmlformats.org/drawingml/2006/main" xmlns:r="http://schemas.openxmlformats.org/officeDocument/2006/relationships" xmlns:p="http://schemas.openxmlformats.org/presentationml/2006/main">
   <p:cSld>
     <p:spTree>
       <p:nvGrpSpPr>
@@ -5787,7 +5937,14 @@
         <p:cNvGrpSpPr/>
         <p:nvPr/>
       </p:nvGrpSpPr>
-      <p:grpSpPr/>
+      <p:grpSpPr>
+        <a:xfrm>
+          <a:off x="0" y="0"/>
+          <a:ext cx="0" cy="0"/>
+          <a:chOff x="0" y="0"/>
+          <a:chExt cx="0" cy="0"/>
+        </a:xfrm>
+      </p:grpSpPr>
       <p:sp>
         <p:nvSpPr>
           <p:cNvPr id="2" name="Rectangle 1"/>
@@ -5828,6 +5985,7 @@
           <a:lstStyle/>
           <a:p>
             <a:pPr algn="ctr"/>
+            <a:endParaRPr/>
           </a:p>
         </p:txBody>
       </p:sp>
@@ -5871,6 +6029,7 @@
           <a:lstStyle/>
           <a:p>
             <a:pPr algn="ctr"/>
+            <a:endParaRPr/>
           </a:p>
         </p:txBody>
       </p:sp>
@@ -5948,6 +6107,7 @@
           <a:lstStyle/>
           <a:p>
             <a:pPr algn="ctr"/>
+            <a:endParaRPr/>
           </a:p>
         </p:txBody>
       </p:sp>
@@ -6368,7 +6528,7 @@
 </file>
 
 <file path=ppt/slides/slide4.xml><?xml version="1.0" encoding="utf-8"?>
-<p:sld xmlns:a="http://schemas.openxmlformats.org/drawingml/2006/main" xmlns:p="http://schemas.openxmlformats.org/presentationml/2006/main" xmlns:r="http://schemas.openxmlformats.org/officeDocument/2006/relationships">
+<p:sld xmlns:a="http://schemas.openxmlformats.org/drawingml/2006/main" xmlns:r="http://schemas.openxmlformats.org/officeDocument/2006/relationships" xmlns:p="http://schemas.openxmlformats.org/presentationml/2006/main">
   <p:cSld>
     <p:spTree>
       <p:nvGrpSpPr>
@@ -6376,7 +6536,14 @@
         <p:cNvGrpSpPr/>
         <p:nvPr/>
       </p:nvGrpSpPr>
-      <p:grpSpPr/>
+      <p:grpSpPr>
+        <a:xfrm>
+          <a:off x="0" y="0"/>
+          <a:ext cx="0" cy="0"/>
+          <a:chOff x="0" y="0"/>
+          <a:chExt cx="0" cy="0"/>
+        </a:xfrm>
+      </p:grpSpPr>
       <p:sp>
         <p:nvSpPr>
           <p:cNvPr id="2" name="Rectangle 1"/>
@@ -6417,6 +6584,7 @@
           <a:lstStyle/>
           <a:p>
             <a:pPr algn="ctr"/>
+            <a:endParaRPr/>
           </a:p>
         </p:txBody>
       </p:sp>
@@ -6460,6 +6628,7 @@
           <a:lstStyle/>
           <a:p>
             <a:pPr algn="ctr"/>
+            <a:endParaRPr/>
           </a:p>
         </p:txBody>
       </p:sp>
@@ -6537,6 +6706,7 @@
           <a:lstStyle/>
           <a:p>
             <a:pPr algn="ctr"/>
+            <a:endParaRPr/>
           </a:p>
         </p:txBody>
       </p:sp>
@@ -6682,6 +6852,7 @@
           <a:lstStyle/>
           <a:p>
             <a:pPr algn="ctr"/>
+            <a:endParaRPr/>
           </a:p>
         </p:txBody>
       </p:sp>
@@ -6881,7 +7052,7 @@
 </file>
 
 <file path=ppt/slides/slide5.xml><?xml version="1.0" encoding="utf-8"?>
-<p:sld xmlns:a="http://schemas.openxmlformats.org/drawingml/2006/main" xmlns:p="http://schemas.openxmlformats.org/presentationml/2006/main" xmlns:r="http://schemas.openxmlformats.org/officeDocument/2006/relationships">
+<p:sld xmlns:a="http://schemas.openxmlformats.org/drawingml/2006/main" xmlns:r="http://schemas.openxmlformats.org/officeDocument/2006/relationships" xmlns:p="http://schemas.openxmlformats.org/presentationml/2006/main">
   <p:cSld>
     <p:spTree>
       <p:nvGrpSpPr>
@@ -6889,7 +7060,14 @@
         <p:cNvGrpSpPr/>
         <p:nvPr/>
       </p:nvGrpSpPr>
-      <p:grpSpPr/>
+      <p:grpSpPr>
+        <a:xfrm>
+          <a:off x="0" y="0"/>
+          <a:ext cx="0" cy="0"/>
+          <a:chOff x="0" y="0"/>
+          <a:chExt cx="0" cy="0"/>
+        </a:xfrm>
+      </p:grpSpPr>
       <p:sp>
         <p:nvSpPr>
           <p:cNvPr id="2" name="Rectangle 1"/>
@@ -6930,6 +7108,7 @@
           <a:lstStyle/>
           <a:p>
             <a:pPr algn="ctr"/>
+            <a:endParaRPr/>
           </a:p>
         </p:txBody>
       </p:sp>
@@ -6973,6 +7152,7 @@
           <a:lstStyle/>
           <a:p>
             <a:pPr algn="ctr"/>
+            <a:endParaRPr/>
           </a:p>
         </p:txBody>
       </p:sp>
@@ -7050,6 +7230,7 @@
           <a:lstStyle/>
           <a:p>
             <a:pPr algn="ctr"/>
+            <a:endParaRPr/>
           </a:p>
         </p:txBody>
       </p:sp>
@@ -7263,6 +7444,7 @@
           <a:lstStyle/>
           <a:p>
             <a:pPr algn="ctr"/>
+            <a:endParaRPr/>
           </a:p>
         </p:txBody>
       </p:sp>
@@ -7325,6 +7507,15 @@
           </a:p>
           <a:p>
             <a:pPr algn="l"/>
+            <a:endParaRPr sz="1200" b="0">
+              <a:solidFill>
+                <a:srgbClr val="333333"/>
+              </a:solidFill>
+              <a:latin typeface="Courier New"/>
+            </a:endParaRPr>
+          </a:p>
+          <a:p>
+            <a:pPr algn="l"/>
             <a:r>
               <a:rPr sz="1200" b="0">
                 <a:solidFill>
@@ -7332,7 +7523,7 @@
                 </a:solidFill>
                 <a:latin typeface="Courier New"/>
               </a:rPr>
-              <a:t/>
+              <a:t>[dev]</a:t>
             </a:r>
           </a:p>
           <a:p>
@@ -7344,8 +7535,17 @@
                 </a:solidFill>
                 <a:latin typeface="Courier New"/>
               </a:rPr>
-              <a:t>[dev]</a:t>
-            </a:r>
+              <a:t>port = 8787          # local: http://localhost:8787</a:t>
+            </a:r>
+          </a:p>
+          <a:p>
+            <a:pPr algn="l"/>
+            <a:endParaRPr sz="1200" b="0">
+              <a:solidFill>
+                <a:srgbClr val="333333"/>
+              </a:solidFill>
+              <a:latin typeface="Courier New"/>
+            </a:endParaRPr>
           </a:p>
           <a:p>
             <a:pPr algn="l"/>
@@ -7356,7 +7556,7 @@
                 </a:solidFill>
                 <a:latin typeface="Courier New"/>
               </a:rPr>
-              <a:t>port = 8787          # local: http://localhost:8787</a:t>
+              <a:t>[vars]</a:t>
             </a:r>
           </a:p>
           <a:p>
@@ -7368,44 +7568,17 @@
                 </a:solidFill>
                 <a:latin typeface="Courier New"/>
               </a:rPr>
-              <a:t/>
-            </a:r>
-          </a:p>
-          <a:p>
-            <a:pPr algn="l"/>
-            <a:r>
-              <a:rPr sz="1200" b="0">
-                <a:solidFill>
-                  <a:srgbClr val="333333"/>
-                </a:solidFill>
-                <a:latin typeface="Courier New"/>
-              </a:rPr>
-              <a:t>[vars]</a:t>
-            </a:r>
-          </a:p>
-          <a:p>
-            <a:pPr algn="l"/>
-            <a:r>
-              <a:rPr sz="1200" b="0">
-                <a:solidFill>
-                  <a:srgbClr val="333333"/>
-                </a:solidFill>
-                <a:latin typeface="Courier New"/>
-              </a:rPr>
               <a:t>API_BASE_URL = "https://author-p12345.adobeaemcloud.com/graphql/execute.json/..."</a:t>
             </a:r>
           </a:p>
           <a:p>
             <a:pPr algn="l"/>
-            <a:r>
-              <a:rPr sz="1200" b="0">
-                <a:solidFill>
-                  <a:srgbClr val="333333"/>
-                </a:solidFill>
-                <a:latin typeface="Courier New"/>
-              </a:rPr>
-              <a:t/>
-            </a:r>
+            <a:endParaRPr sz="1200" b="0">
+              <a:solidFill>
+                <a:srgbClr val="333333"/>
+              </a:solidFill>
+              <a:latin typeface="Courier New"/>
+            </a:endParaRPr>
           </a:p>
           <a:p>
             <a:pPr algn="l"/>
@@ -7534,7 +7707,7 @@
 </file>
 
 <file path=ppt/slides/slide6.xml><?xml version="1.0" encoding="utf-8"?>
-<p:sld xmlns:a="http://schemas.openxmlformats.org/drawingml/2006/main" xmlns:p="http://schemas.openxmlformats.org/presentationml/2006/main" xmlns:r="http://schemas.openxmlformats.org/officeDocument/2006/relationships">
+<p:sld xmlns:a="http://schemas.openxmlformats.org/drawingml/2006/main" xmlns:r="http://schemas.openxmlformats.org/officeDocument/2006/relationships" xmlns:p="http://schemas.openxmlformats.org/presentationml/2006/main">
   <p:cSld>
     <p:spTree>
       <p:nvGrpSpPr>
@@ -7542,7 +7715,14 @@
         <p:cNvGrpSpPr/>
         <p:nvPr/>
       </p:nvGrpSpPr>
-      <p:grpSpPr/>
+      <p:grpSpPr>
+        <a:xfrm>
+          <a:off x="0" y="0"/>
+          <a:ext cx="0" cy="0"/>
+          <a:chOff x="0" y="0"/>
+          <a:chExt cx="0" cy="0"/>
+        </a:xfrm>
+      </p:grpSpPr>
       <p:sp>
         <p:nvSpPr>
           <p:cNvPr id="2" name="Rectangle 1"/>
@@ -7583,6 +7763,7 @@
           <a:lstStyle/>
           <a:p>
             <a:pPr algn="ctr"/>
+            <a:endParaRPr/>
           </a:p>
         </p:txBody>
       </p:sp>
@@ -7626,6 +7807,7 @@
           <a:lstStyle/>
           <a:p>
             <a:pPr algn="ctr"/>
+            <a:endParaRPr/>
           </a:p>
         </p:txBody>
       </p:sp>
@@ -7703,6 +7885,7 @@
           <a:lstStyle/>
           <a:p>
             <a:pPr algn="ctr"/>
+            <a:endParaRPr/>
           </a:p>
         </p:txBody>
       </p:sp>
@@ -7950,6 +8133,7 @@
           <a:lstStyle/>
           <a:p>
             <a:pPr algn="ctr"/>
+            <a:endParaRPr/>
           </a:p>
         </p:txBody>
       </p:sp>
@@ -8036,6 +8220,15 @@
           </a:p>
           <a:p>
             <a:pPr algn="l"/>
+            <a:endParaRPr sz="1200" b="0">
+              <a:solidFill>
+                <a:srgbClr val="333333"/>
+              </a:solidFill>
+              <a:latin typeface="Courier New"/>
+            </a:endParaRPr>
+          </a:p>
+          <a:p>
+            <a:pPr algn="l"/>
             <a:r>
               <a:rPr sz="1200" b="0">
                 <a:solidFill>
@@ -8043,7 +8236,7 @@
                 </a:solidFill>
                 <a:latin typeface="Courier New"/>
               </a:rPr>
-              <a:t/>
+              <a:t>function corsHeaders(origin) {</a:t>
             </a:r>
           </a:p>
           <a:p>
@@ -8055,7 +8248,7 @@
                 </a:solidFill>
                 <a:latin typeface="Courier New"/>
               </a:rPr>
-              <a:t>function corsHeaders(origin) {</a:t>
+              <a:t>  const allow = ALLOWED_ORIGINS.includes(origin) ? origin : ALLOWED_ORIGINS[0];</a:t>
             </a:r>
           </a:p>
           <a:p>
@@ -8067,7 +8260,7 @@
                 </a:solidFill>
                 <a:latin typeface="Courier New"/>
               </a:rPr>
-              <a:t>  const allow = ALLOWED_ORIGINS.includes(origin) ? origin : ALLOWED_ORIGINS[0];</a:t>
+              <a:t>  return { 'Access-Control-Allow-Origin': allow,</a:t>
             </a:r>
           </a:p>
           <a:p>
@@ -8079,7 +8272,7 @@
                 </a:solidFill>
                 <a:latin typeface="Courier New"/>
               </a:rPr>
-              <a:t>  return { 'Access-Control-Allow-Origin': allow,</a:t>
+              <a:t>           'Access-Control-Allow-Methods': 'GET, OPTIONS' };</a:t>
             </a:r>
           </a:p>
           <a:p>
@@ -8091,32 +8284,17 @@
                 </a:solidFill>
                 <a:latin typeface="Courier New"/>
               </a:rPr>
-              <a:t>           'Access-Control-Allow-Methods': 'GET, OPTIONS' };</a:t>
-            </a:r>
-          </a:p>
-          <a:p>
-            <a:pPr algn="l"/>
-            <a:r>
-              <a:rPr sz="1200" b="0">
-                <a:solidFill>
-                  <a:srgbClr val="333333"/>
-                </a:solidFill>
-                <a:latin typeface="Courier New"/>
-              </a:rPr>
               <a:t>}</a:t>
             </a:r>
           </a:p>
           <a:p>
             <a:pPr algn="l"/>
-            <a:r>
-              <a:rPr sz="1200" b="0">
-                <a:solidFill>
-                  <a:srgbClr val="333333"/>
-                </a:solidFill>
-                <a:latin typeface="Courier New"/>
-              </a:rPr>
-              <a:t/>
-            </a:r>
+            <a:endParaRPr sz="1200" b="0">
+              <a:solidFill>
+                <a:srgbClr val="333333"/>
+              </a:solidFill>
+              <a:latin typeface="Courier New"/>
+            </a:endParaRPr>
           </a:p>
           <a:p>
             <a:pPr algn="l"/>
@@ -8317,7 +8495,7 @@
 </file>
 
 <file path=ppt/slides/slide7.xml><?xml version="1.0" encoding="utf-8"?>
-<p:sld xmlns:a="http://schemas.openxmlformats.org/drawingml/2006/main" xmlns:p="http://schemas.openxmlformats.org/presentationml/2006/main" xmlns:r="http://schemas.openxmlformats.org/officeDocument/2006/relationships">
+<p:sld xmlns:a="http://schemas.openxmlformats.org/drawingml/2006/main" xmlns:r="http://schemas.openxmlformats.org/officeDocument/2006/relationships" xmlns:p="http://schemas.openxmlformats.org/presentationml/2006/main">
   <p:cSld>
     <p:spTree>
       <p:nvGrpSpPr>
@@ -8325,7 +8503,14 @@
         <p:cNvGrpSpPr/>
         <p:nvPr/>
       </p:nvGrpSpPr>
-      <p:grpSpPr/>
+      <p:grpSpPr>
+        <a:xfrm>
+          <a:off x="0" y="0"/>
+          <a:ext cx="0" cy="0"/>
+          <a:chOff x="0" y="0"/>
+          <a:chExt cx="0" cy="0"/>
+        </a:xfrm>
+      </p:grpSpPr>
       <p:sp>
         <p:nvSpPr>
           <p:cNvPr id="2" name="Rectangle 1"/>
@@ -8366,6 +8551,7 @@
           <a:lstStyle/>
           <a:p>
             <a:pPr algn="ctr"/>
+            <a:endParaRPr/>
           </a:p>
         </p:txBody>
       </p:sp>
@@ -8409,6 +8595,7 @@
           <a:lstStyle/>
           <a:p>
             <a:pPr algn="ctr"/>
+            <a:endParaRPr/>
           </a:p>
         </p:txBody>
       </p:sp>
@@ -8486,6 +8673,7 @@
           <a:lstStyle/>
           <a:p>
             <a:pPr algn="ctr"/>
+            <a:endParaRPr/>
           </a:p>
         </p:txBody>
       </p:sp>
@@ -8974,7 +9162,7 @@
 </file>
 
 <file path=ppt/slides/slide8.xml><?xml version="1.0" encoding="utf-8"?>
-<p:sld xmlns:a="http://schemas.openxmlformats.org/drawingml/2006/main" xmlns:p="http://schemas.openxmlformats.org/presentationml/2006/main" xmlns:r="http://schemas.openxmlformats.org/officeDocument/2006/relationships">
+<p:sld xmlns:a="http://schemas.openxmlformats.org/drawingml/2006/main" xmlns:r="http://schemas.openxmlformats.org/officeDocument/2006/relationships" xmlns:p="http://schemas.openxmlformats.org/presentationml/2006/main">
   <p:cSld>
     <p:spTree>
       <p:nvGrpSpPr>
@@ -8982,7 +9170,14 @@
         <p:cNvGrpSpPr/>
         <p:nvPr/>
       </p:nvGrpSpPr>
-      <p:grpSpPr/>
+      <p:grpSpPr>
+        <a:xfrm>
+          <a:off x="0" y="0"/>
+          <a:ext cx="0" cy="0"/>
+          <a:chOff x="0" y="0"/>
+          <a:chExt cx="0" cy="0"/>
+        </a:xfrm>
+      </p:grpSpPr>
       <p:sp>
         <p:nvSpPr>
           <p:cNvPr id="2" name="Rectangle 1"/>
@@ -9023,6 +9218,7 @@
           <a:lstStyle/>
           <a:p>
             <a:pPr algn="ctr"/>
+            <a:endParaRPr/>
           </a:p>
         </p:txBody>
       </p:sp>
@@ -9066,6 +9262,7 @@
           <a:lstStyle/>
           <a:p>
             <a:pPr algn="ctr"/>
+            <a:endParaRPr/>
           </a:p>
         </p:txBody>
       </p:sp>
@@ -9143,6 +9340,7 @@
           <a:lstStyle/>
           <a:p>
             <a:pPr algn="ctr"/>
+            <a:endParaRPr/>
           </a:p>
         </p:txBody>
       </p:sp>
@@ -9322,6 +9520,7 @@
           <a:lstStyle/>
           <a:p>
             <a:pPr algn="ctr"/>
+            <a:endParaRPr/>
           </a:p>
         </p:txBody>
       </p:sp>
@@ -9372,6 +9571,15 @@
           </a:p>
           <a:p>
             <a:pPr algn="l"/>
+            <a:endParaRPr sz="1200" b="0">
+              <a:solidFill>
+                <a:srgbClr val="333333"/>
+              </a:solidFill>
+              <a:latin typeface="Courier New"/>
+            </a:endParaRPr>
+          </a:p>
+          <a:p>
+            <a:pPr algn="l"/>
             <a:r>
               <a:rPr sz="1200" b="0">
                 <a:solidFill>
@@ -9379,7 +9587,7 @@
                 </a:solidFill>
                 <a:latin typeface="Courier New"/>
               </a:rPr>
-              <a:t/>
+              <a:t># 2. Deploy</a:t>
             </a:r>
           </a:p>
           <a:p>
@@ -9391,7 +9599,7 @@
                 </a:solidFill>
                 <a:latin typeface="Courier New"/>
               </a:rPr>
-              <a:t># 2. Deploy</a:t>
+              <a:t>npm run deploy:edge</a:t>
             </a:r>
           </a:p>
           <a:p>
@@ -9403,8 +9611,17 @@
                 </a:solidFill>
                 <a:latin typeface="Courier New"/>
               </a:rPr>
-              <a:t>npm run deploy:edge</a:t>
-            </a:r>
+              <a:t>#  └─ runs: wrangler deploy</a:t>
+            </a:r>
+          </a:p>
+          <a:p>
+            <a:pPr algn="l"/>
+            <a:endParaRPr sz="1200" b="0">
+              <a:solidFill>
+                <a:srgbClr val="333333"/>
+              </a:solidFill>
+              <a:latin typeface="Courier New"/>
+            </a:endParaRPr>
           </a:p>
           <a:p>
             <a:pPr algn="l"/>
@@ -9415,7 +9632,7 @@
                 </a:solidFill>
                 <a:latin typeface="Courier New"/>
               </a:rPr>
-              <a:t>#  └─ runs: wrangler deploy</a:t>
+              <a:t># 3. Verify</a:t>
             </a:r>
           </a:p>
           <a:p>
@@ -9427,7 +9644,7 @@
                 </a:solidFill>
                 <a:latin typeface="Courier New"/>
               </a:rPr>
-              <a:t/>
+              <a:t>npx wrangler tail            # stream live request logs</a:t>
             </a:r>
           </a:p>
           <a:p>
@@ -9439,44 +9656,17 @@
                 </a:solidFill>
                 <a:latin typeface="Courier New"/>
               </a:rPr>
-              <a:t># 3. Verify</a:t>
-            </a:r>
-          </a:p>
-          <a:p>
-            <a:pPr algn="l"/>
-            <a:r>
-              <a:rPr sz="1200" b="0">
-                <a:solidFill>
-                  <a:srgbClr val="333333"/>
-                </a:solidFill>
-                <a:latin typeface="Courier New"/>
-              </a:rPr>
-              <a:t>npx wrangler tail            # stream live request logs</a:t>
-            </a:r>
-          </a:p>
-          <a:p>
-            <a:pPr algn="l"/>
-            <a:r>
-              <a:rPr sz="1200" b="0">
-                <a:solidFill>
-                  <a:srgbClr val="333333"/>
-                </a:solidFill>
-                <a:latin typeface="Courier New"/>
-              </a:rPr>
               <a:t>curl https://myeds-xwalk-api.fsevin.workers.dev/api/geocode?name=Paris</a:t>
             </a:r>
           </a:p>
           <a:p>
             <a:pPr algn="l"/>
-            <a:r>
-              <a:rPr sz="1200" b="0">
-                <a:solidFill>
-                  <a:srgbClr val="333333"/>
-                </a:solidFill>
-                <a:latin typeface="Courier New"/>
-              </a:rPr>
-              <a:t/>
-            </a:r>
+            <a:endParaRPr sz="1200" b="0">
+              <a:solidFill>
+                <a:srgbClr val="333333"/>
+              </a:solidFill>
+              <a:latin typeface="Courier New"/>
+            </a:endParaRPr>
           </a:p>
           <a:p>
             <a:pPr algn="l"/>
@@ -9617,7 +9807,7 @@
 </file>
 
 <file path=ppt/slides/slide9.xml><?xml version="1.0" encoding="utf-8"?>
-<p:sld xmlns:a="http://schemas.openxmlformats.org/drawingml/2006/main" xmlns:p="http://schemas.openxmlformats.org/presentationml/2006/main" xmlns:r="http://schemas.openxmlformats.org/officeDocument/2006/relationships">
+<p:sld xmlns:a="http://schemas.openxmlformats.org/drawingml/2006/main" xmlns:r="http://schemas.openxmlformats.org/officeDocument/2006/relationships" xmlns:p="http://schemas.openxmlformats.org/presentationml/2006/main">
   <p:cSld>
     <p:spTree>
       <p:nvGrpSpPr>
@@ -9625,7 +9815,14 @@
         <p:cNvGrpSpPr/>
         <p:nvPr/>
       </p:nvGrpSpPr>
-      <p:grpSpPr/>
+      <p:grpSpPr>
+        <a:xfrm>
+          <a:off x="0" y="0"/>
+          <a:ext cx="0" cy="0"/>
+          <a:chOff x="0" y="0"/>
+          <a:chExt cx="0" cy="0"/>
+        </a:xfrm>
+      </p:grpSpPr>
       <p:sp>
         <p:nvSpPr>
           <p:cNvPr id="2" name="Rectangle 1"/>
@@ -9666,6 +9863,7 @@
           <a:lstStyle/>
           <a:p>
             <a:pPr algn="ctr"/>
+            <a:endParaRPr/>
           </a:p>
         </p:txBody>
       </p:sp>
@@ -9709,6 +9907,7 @@
           <a:lstStyle/>
           <a:p>
             <a:pPr algn="ctr"/>
+            <a:endParaRPr/>
           </a:p>
         </p:txBody>
       </p:sp>
@@ -9786,6 +9985,7 @@
           <a:lstStyle/>
           <a:p>
             <a:pPr algn="ctr"/>
+            <a:endParaRPr/>
           </a:p>
         </p:txBody>
       </p:sp>
@@ -9999,6 +10199,7 @@
           <a:lstStyle/>
           <a:p>
             <a:pPr algn="ctr"/>
+            <a:endParaRPr/>
           </a:p>
         </p:txBody>
       </p:sp>
@@ -10037,6 +10238,15 @@
           </a:p>
           <a:p>
             <a:pPr algn="l"/>
+            <a:endParaRPr sz="1200" b="0">
+              <a:solidFill>
+                <a:srgbClr val="333333"/>
+              </a:solidFill>
+              <a:latin typeface="Courier New"/>
+            </a:endParaRPr>
+          </a:p>
+          <a:p>
+            <a:pPr algn="l"/>
             <a:r>
               <a:rPr sz="1200" b="0">
                 <a:solidFill>
@@ -10044,7 +10254,7 @@
                 </a:solidFill>
                 <a:latin typeface="Courier New"/>
               </a:rPr>
-              <a:t/>
+              <a:t>const EDGE_ORIGIN = window.location.hostname === 'localhost'</a:t>
             </a:r>
           </a:p>
           <a:p>
@@ -10056,7 +10266,7 @@
                 </a:solidFill>
                 <a:latin typeface="Courier New"/>
               </a:rPr>
-              <a:t>const EDGE_ORIGIN = window.location.hostname === 'localhost'</a:t>
+              <a:t>  ? 'http://localhost:8787'</a:t>
             </a:r>
           </a:p>
           <a:p>
@@ -10068,8 +10278,17 @@
                 </a:solidFill>
                 <a:latin typeface="Courier New"/>
               </a:rPr>
-              <a:t>  ? 'http://localhost:8787'</a:t>
-            </a:r>
+              <a:t>  : 'https://myeds-xwalk-api.fsevin.workers.dev';</a:t>
+            </a:r>
+          </a:p>
+          <a:p>
+            <a:pPr algn="l"/>
+            <a:endParaRPr sz="1200" b="0">
+              <a:solidFill>
+                <a:srgbClr val="333333"/>
+              </a:solidFill>
+              <a:latin typeface="Courier New"/>
+            </a:endParaRPr>
           </a:p>
           <a:p>
             <a:pPr algn="l"/>
@@ -10080,7 +10299,7 @@
                 </a:solidFill>
                 <a:latin typeface="Courier New"/>
               </a:rPr>
-              <a:t>  : 'https://myeds-xwalk-api.fsevin.workers.dev';</a:t>
+              <a:t>async function fetchJSON(url) {</a:t>
             </a:r>
           </a:p>
           <a:p>
@@ -10092,7 +10311,7 @@
                 </a:solidFill>
                 <a:latin typeface="Courier New"/>
               </a:rPr>
-              <a:t/>
+              <a:t>  const res = await fetch(url);</a:t>
             </a:r>
           </a:p>
           <a:p>
@@ -10104,7 +10323,7 @@
                 </a:solidFill>
                 <a:latin typeface="Courier New"/>
               </a:rPr>
-              <a:t>async function fetchJSON(url) {</a:t>
+              <a:t>  if (!res.ok) throw new Error(\`HTTP \${res.status}\`);</a:t>
             </a:r>
           </a:p>
           <a:p>
@@ -10116,7 +10335,7 @@
                 </a:solidFill>
                 <a:latin typeface="Courier New"/>
               </a:rPr>
-              <a:t>  const res = await fetch(url);</a:t>
+              <a:t>  return res.json();</a:t>
             </a:r>
           </a:p>
           <a:p>
@@ -10128,8 +10347,17 @@
                 </a:solidFill>
                 <a:latin typeface="Courier New"/>
               </a:rPr>
-              <a:t>  if (!res.ok) throw new Error(\`HTTP \${res.status}\`);</a:t>
-            </a:r>
+              <a:t>}</a:t>
+            </a:r>
+          </a:p>
+          <a:p>
+            <a:pPr algn="l"/>
+            <a:endParaRPr sz="1200" b="0">
+              <a:solidFill>
+                <a:srgbClr val="333333"/>
+              </a:solidFill>
+              <a:latin typeface="Courier New"/>
+            </a:endParaRPr>
           </a:p>
           <a:p>
             <a:pPr algn="l"/>
@@ -10140,7 +10368,7 @@
                 </a:solidFill>
                 <a:latin typeface="Courier New"/>
               </a:rPr>
-              <a:t>  return res.json();</a:t>
+              <a:t>export default async function decorate(block) {</a:t>
             </a:r>
           </a:p>
           <a:p>
@@ -10152,7 +10380,7 @@
                 </a:solidFill>
                 <a:latin typeface="Courier New"/>
               </a:rPr>
-              <a:t>}</a:t>
+              <a:t>  // Read location from first cell (works with both &lt;p&gt; and &lt;div&gt; content)</a:t>
             </a:r>
           </a:p>
           <a:p>
@@ -10164,7 +10392,7 @@
                 </a:solidFill>
                 <a:latin typeface="Courier New"/>
               </a:rPr>
-              <a:t/>
+              <a:t>  const location = block.querySelector('div:first-child p, div:first-child div')</a:t>
             </a:r>
           </a:p>
           <a:p>
@@ -10176,56 +10404,17 @@
                 </a:solidFill>
                 <a:latin typeface="Courier New"/>
               </a:rPr>
-              <a:t>export default async function decorate(block) {</a:t>
-            </a:r>
-          </a:p>
-          <a:p>
-            <a:pPr algn="l"/>
-            <a:r>
-              <a:rPr sz="1200" b="0">
-                <a:solidFill>
-                  <a:srgbClr val="333333"/>
-                </a:solidFill>
-                <a:latin typeface="Courier New"/>
-              </a:rPr>
-              <a:t>  // Read location from first cell (works with both &lt;p&gt; and &lt;div&gt; content)</a:t>
-            </a:r>
-          </a:p>
-          <a:p>
-            <a:pPr algn="l"/>
-            <a:r>
-              <a:rPr sz="1200" b="0">
-                <a:solidFill>
-                  <a:srgbClr val="333333"/>
-                </a:solidFill>
-                <a:latin typeface="Courier New"/>
-              </a:rPr>
-              <a:t>  const location = block.querySelector('div:first-child p, div:first-child div')</a:t>
-            </a:r>
-          </a:p>
-          <a:p>
-            <a:pPr algn="l"/>
-            <a:r>
-              <a:rPr sz="1200" b="0">
-                <a:solidFill>
-                  <a:srgbClr val="333333"/>
-                </a:solidFill>
-                <a:latin typeface="Courier New"/>
-              </a:rPr>
               <a:t>    ?.textContent?.trim() || '';</a:t>
             </a:r>
           </a:p>
           <a:p>
             <a:pPr algn="l"/>
-            <a:r>
-              <a:rPr sz="1200" b="0">
-                <a:solidFill>
-                  <a:srgbClr val="333333"/>
-                </a:solidFill>
-                <a:latin typeface="Courier New"/>
-              </a:rPr>
-              <a:t/>
-            </a:r>
+            <a:endParaRPr sz="1200" b="0">
+              <a:solidFill>
+                <a:srgbClr val="333333"/>
+              </a:solidFill>
+              <a:latin typeface="Courier New"/>
+            </a:endParaRPr>
           </a:p>
           <a:p>
             <a:pPr algn="l"/>

</xml_diff>